<commit_message>
Update prompts and Gemini client to improve C# code generation robustness, add retry logic, and include final presentations
</commit_message>
<xml_diff>
--- a/WebLegacy_AI_Praesentation_V3.pptx
+++ b/WebLegacy_AI_Praesentation_V3.pptx
@@ -6187,7 +6187,19 @@
               </a:defRPr>
             </a:pPr>
             <a:r>
-              <a:t>1. Spaghetti-Code &amp; Relationale Komplexität</a:t>
+              <a:rPr dirty="0"/>
+              <a:t>1. Spaghetti-Code &amp; </a:t>
+            </a:r>
+            <a:r>
+              <a:rPr dirty="0" err="1"/>
+              <a:t>Relationale</a:t>
+            </a:r>
+            <a:r>
+              <a:rPr dirty="0"/>
+              <a:t> </a:t>
+            </a:r>
+            <a:r>
+              <a:t>Komplexität</a:t>
             </a:r>
           </a:p>
           <a:p>
@@ -6200,7 +6212,64 @@
               </a:defRPr>
             </a:pPr>
             <a:r>
-              <a:t>HTML-Dashboard, Logik und Datenbankabfragen sind wild in PHP vermischt. 9 Tabellen mit komplexen Relationen.</a:t>
+              <a:rPr dirty="0"/>
+              <a:t>HTML-Dashboard, Logik und </a:t>
+            </a:r>
+            <a:r>
+              <a:rPr dirty="0" err="1"/>
+              <a:t>Datenbankabfragen</a:t>
+            </a:r>
+            <a:r>
+              <a:rPr dirty="0"/>
+              <a:t> </a:t>
+            </a:r>
+            <a:r>
+              <a:rPr dirty="0" err="1"/>
+              <a:t>sind</a:t>
+            </a:r>
+            <a:r>
+              <a:rPr dirty="0"/>
+              <a:t> wild in PHP </a:t>
+            </a:r>
+            <a:r>
+              <a:rPr dirty="0" err="1"/>
+              <a:t>vermischt</a:t>
+            </a:r>
+            <a:r>
+              <a:rPr dirty="0"/>
+              <a:t>. 9 </a:t>
+            </a:r>
+            <a:r>
+              <a:rPr dirty="0" err="1"/>
+              <a:t>Tabellen</a:t>
+            </a:r>
+            <a:r>
+              <a:rPr dirty="0"/>
+              <a:t> </a:t>
+            </a:r>
+            <a:r>
+              <a:rPr dirty="0" err="1"/>
+              <a:t>mit</a:t>
+            </a:r>
+            <a:r>
+              <a:rPr dirty="0"/>
+              <a:t> </a:t>
+            </a:r>
+            <a:r>
+              <a:rPr dirty="0" err="1"/>
+              <a:t>komplexen</a:t>
+            </a:r>
+            <a:r>
+              <a:rPr dirty="0"/>
+              <a:t> </a:t>
+            </a:r>
+            <a:r>
+              <a:rPr dirty="0" err="1"/>
+              <a:t>Relationen</a:t>
+            </a:r>
+            <a:r>
+              <a:rPr dirty="0"/>
+              <a:t>.</a:t>
             </a:r>
           </a:p>
         </p:txBody>

</xml_diff>